<commit_message>
Restore candidate profile links in Freedom Plan v2
Co-Authored-By: Claude Opus 5.5 <noreply@anthropic.com>
Claude-Session: https://claude.ai/code/session_01TQevHxB1x7vFaQYb7c58XF
</commit_message>
<xml_diff>
--- a/Yasmine_Johnson_Freedom_Plan_v2.pptx
+++ b/Yasmine_Johnson_Freedom_Plan_v2.pptx
@@ -132,17 +132,17 @@
   <p:extLst>
     <p:ext uri="{521415D9-36F7-43E2-AB2F-B90AF26B5E84}">
       <p14:sectionLst xmlns:p14="http://schemas.microsoft.com/office/powerpoint/2010/main">
-        <p14:section name="Cover" id="{dc74dc4b-953d-2f85-a600-8e8b2e18706d}">
+        <p14:section name="Cover" id="{40b28a20-1165-ffca-2ae7-c7539050c15f}">
           <p14:sldIdLst>
             <p14:sldId id="256"/>
           </p14:sldIdLst>
         </p14:section>
-        <p14:section name="Getting oriented" id="{fc1c2c37-30f9-4794-f32f-3a4522f612c6}">
+        <p14:section name="Getting oriented" id="{8a81afcc-a61d-bf03-941c-bbf47945c8a2}">
           <p14:sldIdLst>
             <p14:sldId id="257"/>
           </p14:sldIdLst>
         </p14:section>
-        <p14:section name="Part A: Our Recommendation" id="{de58661e-a2b6-8dbe-a33e-688c3b8c2313}">
+        <p14:section name="Part A: Our Recommendation" id="{abbb569c-2049-abf4-0358-4078a73a78f7}">
           <p14:sldIdLst>
             <p14:sldId id="258"/>
             <p14:sldId id="259"/>
@@ -155,7 +155,7 @@
             <p14:sldId id="266"/>
           </p14:sldIdLst>
         </p14:section>
-        <p14:section name="Part B: Your Freedom Playbook" id="{8c3355ef-2de0-3e55-872a-9adfe0b53d9c}">
+        <p14:section name="Part B: Your Freedom Playbook" id="{0436cb70-ec84-ecc1-4e16-c5510f87cf6a}">
           <p14:sldIdLst>
             <p14:sldId id="267"/>
             <p14:sldId id="268"/>
@@ -32464,7 +32464,7 @@
                   <a:schemeClr val="accent3"/>
                 </a:solidFill>
               </a:rPr>
-              <a:t>Shortlisted for your Alignment Session. Full profiles available via the links shared by our Recruitment team.</a:t>
+              <a:t>Shortlisted for your Alignment Session. Click through to each candidate’s full profile.</a:t>
             </a:r>
             <a:endParaRPr lang="en-US" sz="1300" dirty="0"/>
           </a:p>
@@ -32640,7 +32640,7 @@
         <p:spPr>
           <a:xfrm>
             <a:off x="905256" y="3063240"/>
-            <a:ext cx="2972714" cy="2103120"/>
+            <a:ext cx="2972714" cy="1554480"/>
           </a:xfrm>
           <a:prstGeom prst="rect">
             <a:avLst/>
@@ -32669,7 +32669,50 @@
       </p:sp>
       <p:sp>
         <p:nvSpPr>
-          <p:cNvPr id="11" name="card"/>
+          <p:cNvPr id="11" name="Text 9"/>
+          <p:cNvSpPr txBox="1"/>
+          <p:nvPr/>
+        </p:nvSpPr>
+        <p:spPr>
+          <a:xfrm>
+            <a:off x="905256" y="4754880"/>
+            <a:ext cx="2972714" cy="320040"/>
+          </a:xfrm>
+          <a:prstGeom prst="rect">
+            <a:avLst/>
+          </a:prstGeom>
+          <a:noFill/>
+          <a:ln/>
+        </p:spPr>
+        <p:txBody>
+          <a:bodyPr wrap="square" lIns="0" tIns="0" rIns="0" bIns="0" rtlCol="0" anchor="ctr"/>
+          <a:lstStyle/>
+          <a:p>
+            <a:pPr indent="0" marL="0">
+              <a:buNone/>
+            </a:pPr>
+            <a:r>
+              <a:rPr lang="en-US" sz="1200" b="1" u="sng" dirty="0">
+                <a:solidFill>
+                  <a:schemeClr val="accent1"/>
+                </a:solidFill>
+                <a:hlinkClick r:id="rId1" invalidUrl="" action="" tgtFrame="" tooltip="" history="1" highlightClick="0" endSnd="0">
+                  <a:extLst>
+                    <a:ext uri="{A12FA001-AC4F-418D-AE19-62706E023703}">
+                      <ahyp:hlinkClr xmlns:ahyp="http://schemas.microsoft.com/office/drawing/2018/hyperlinkcolor" val="tx"/>
+                    </a:ext>
+                  </a:extLst>
+                </a:hlinkClick>
+              </a:rPr>
+              <a:t>View full profile →</a:t>
+            </a:r>
+            <a:endParaRPr lang="en-US" sz="1200" dirty="0"/>
+          </a:p>
+        </p:txBody>
+      </p:sp>
+      <p:sp>
+        <p:nvSpPr>
+          <p:cNvPr id="12" name="card"/>
           <p:cNvSpPr/>
           <p:nvPr/>
         </p:nvSpPr>
@@ -32696,7 +32739,7 @@
       </p:sp>
       <p:sp>
         <p:nvSpPr>
-          <p:cNvPr id="12" name="avatar Valerie"/>
+          <p:cNvPr id="13" name="avatar Valerie"/>
           <p:cNvSpPr/>
           <p:nvPr/>
         </p:nvSpPr>
@@ -32716,7 +32759,7 @@
       </p:sp>
       <p:sp>
         <p:nvSpPr>
-          <p:cNvPr id="13" name="Text 11"/>
+          <p:cNvPr id="14" name="Text 12"/>
           <p:cNvSpPr txBox="1"/>
           <p:nvPr/>
         </p:nvSpPr>
@@ -32755,7 +32798,7 @@
       </p:sp>
       <p:sp>
         <p:nvSpPr>
-          <p:cNvPr id="14" name="Text 12"/>
+          <p:cNvPr id="15" name="Text 13"/>
           <p:cNvSpPr txBox="1"/>
           <p:nvPr/>
         </p:nvSpPr>
@@ -32794,7 +32837,7 @@
       </p:sp>
       <p:sp>
         <p:nvSpPr>
-          <p:cNvPr id="15" name="Text 13"/>
+          <p:cNvPr id="16" name="Text 14"/>
           <p:cNvSpPr txBox="1"/>
           <p:nvPr/>
         </p:nvSpPr>
@@ -32830,14 +32873,14 @@
       </p:sp>
       <p:sp>
         <p:nvSpPr>
-          <p:cNvPr id="16" name="Text 14"/>
+          <p:cNvPr id="17" name="Text 15"/>
           <p:cNvSpPr txBox="1"/>
           <p:nvPr/>
         </p:nvSpPr>
         <p:spPr>
           <a:xfrm>
             <a:off x="4609490" y="3063240"/>
-            <a:ext cx="2972714" cy="2103120"/>
+            <a:ext cx="2972714" cy="1554480"/>
           </a:xfrm>
           <a:prstGeom prst="rect">
             <a:avLst/>
@@ -32866,7 +32909,50 @@
       </p:sp>
       <p:sp>
         <p:nvSpPr>
-          <p:cNvPr id="17" name="card"/>
+          <p:cNvPr id="18" name="Text 16"/>
+          <p:cNvSpPr txBox="1"/>
+          <p:nvPr/>
+        </p:nvSpPr>
+        <p:spPr>
+          <a:xfrm>
+            <a:off x="4609490" y="4754880"/>
+            <a:ext cx="2972714" cy="320040"/>
+          </a:xfrm>
+          <a:prstGeom prst="rect">
+            <a:avLst/>
+          </a:prstGeom>
+          <a:noFill/>
+          <a:ln/>
+        </p:spPr>
+        <p:txBody>
+          <a:bodyPr wrap="square" lIns="0" tIns="0" rIns="0" bIns="0" rtlCol="0" anchor="ctr"/>
+          <a:lstStyle/>
+          <a:p>
+            <a:pPr indent="0" marL="0">
+              <a:buNone/>
+            </a:pPr>
+            <a:r>
+              <a:rPr lang="en-US" sz="1200" b="1" u="sng" dirty="0">
+                <a:solidFill>
+                  <a:schemeClr val="accent1"/>
+                </a:solidFill>
+                <a:hlinkClick r:id="rId2" invalidUrl="" action="" tgtFrame="" tooltip="" history="1" highlightClick="0" endSnd="0">
+                  <a:extLst>
+                    <a:ext uri="{A12FA001-AC4F-418D-AE19-62706E023703}">
+                      <ahyp:hlinkClr xmlns:ahyp="http://schemas.microsoft.com/office/drawing/2018/hyperlinkcolor" val="tx"/>
+                    </a:ext>
+                  </a:extLst>
+                </a:hlinkClick>
+              </a:rPr>
+              <a:t>View full profile →</a:t>
+            </a:r>
+            <a:endParaRPr lang="en-US" sz="1200" dirty="0"/>
+          </a:p>
+        </p:txBody>
+      </p:sp>
+      <p:sp>
+        <p:nvSpPr>
+          <p:cNvPr id="19" name="card"/>
           <p:cNvSpPr/>
           <p:nvPr/>
         </p:nvSpPr>
@@ -32893,7 +32979,7 @@
       </p:sp>
       <p:sp>
         <p:nvSpPr>
-          <p:cNvPr id="18" name="avatar Nikara"/>
+          <p:cNvPr id="20" name="avatar Nikara"/>
           <p:cNvSpPr/>
           <p:nvPr/>
         </p:nvSpPr>
@@ -32913,7 +32999,7 @@
       </p:sp>
       <p:sp>
         <p:nvSpPr>
-          <p:cNvPr id="19" name="Text 17"/>
+          <p:cNvPr id="21" name="Text 19"/>
           <p:cNvSpPr txBox="1"/>
           <p:nvPr/>
         </p:nvSpPr>
@@ -32952,7 +33038,7 @@
       </p:sp>
       <p:sp>
         <p:nvSpPr>
-          <p:cNvPr id="20" name="Text 18"/>
+          <p:cNvPr id="22" name="Text 20"/>
           <p:cNvSpPr txBox="1"/>
           <p:nvPr/>
         </p:nvSpPr>
@@ -32991,7 +33077,7 @@
       </p:sp>
       <p:sp>
         <p:nvSpPr>
-          <p:cNvPr id="21" name="Text 19"/>
+          <p:cNvPr id="23" name="Text 21"/>
           <p:cNvSpPr txBox="1"/>
           <p:nvPr/>
         </p:nvSpPr>
@@ -33027,14 +33113,14 @@
       </p:sp>
       <p:sp>
         <p:nvSpPr>
-          <p:cNvPr id="22" name="Text 20"/>
+          <p:cNvPr id="24" name="Text 22"/>
           <p:cNvSpPr txBox="1"/>
           <p:nvPr/>
         </p:nvSpPr>
         <p:spPr>
           <a:xfrm>
             <a:off x="8313725" y="3063240"/>
-            <a:ext cx="2972714" cy="2103120"/>
+            <a:ext cx="2972714" cy="1554480"/>
           </a:xfrm>
           <a:prstGeom prst="rect">
             <a:avLst/>
@@ -33063,7 +33149,50 @@
       </p:sp>
       <p:sp>
         <p:nvSpPr>
-          <p:cNvPr id="23" name="Text 21"/>
+          <p:cNvPr id="25" name="Text 23"/>
+          <p:cNvSpPr txBox="1"/>
+          <p:nvPr/>
+        </p:nvSpPr>
+        <p:spPr>
+          <a:xfrm>
+            <a:off x="8313725" y="4754880"/>
+            <a:ext cx="2972714" cy="320040"/>
+          </a:xfrm>
+          <a:prstGeom prst="rect">
+            <a:avLst/>
+          </a:prstGeom>
+          <a:noFill/>
+          <a:ln/>
+        </p:spPr>
+        <p:txBody>
+          <a:bodyPr wrap="square" lIns="0" tIns="0" rIns="0" bIns="0" rtlCol="0" anchor="ctr"/>
+          <a:lstStyle/>
+          <a:p>
+            <a:pPr indent="0" marL="0">
+              <a:buNone/>
+            </a:pPr>
+            <a:r>
+              <a:rPr lang="en-US" sz="1200" b="1" u="sng" dirty="0">
+                <a:solidFill>
+                  <a:schemeClr val="accent1"/>
+                </a:solidFill>
+                <a:hlinkClick r:id="rId3" invalidUrl="" action="" tgtFrame="" tooltip="" history="1" highlightClick="0" endSnd="0">
+                  <a:extLst>
+                    <a:ext uri="{A12FA001-AC4F-418D-AE19-62706E023703}">
+                      <ahyp:hlinkClr xmlns:ahyp="http://schemas.microsoft.com/office/drawing/2018/hyperlinkcolor" val="tx"/>
+                    </a:ext>
+                  </a:extLst>
+                </a:hlinkClick>
+              </a:rPr>
+              <a:t>View full profile →</a:t>
+            </a:r>
+            <a:endParaRPr lang="en-US" sz="1200" dirty="0"/>
+          </a:p>
+        </p:txBody>
+      </p:sp>
+      <p:sp>
+        <p:nvSpPr>
+          <p:cNvPr id="26" name="Text 24"/>
           <p:cNvSpPr txBox="1"/>
           <p:nvPr/>
         </p:nvSpPr>

</xml_diff>